<commit_message>
marketing-studio: Canva 이관 PPTX 폰트를 Noto Sans KR로 대체, 텍스트박스 여유폭 확보
Canva 가져오기에서 Pretendard가 인식되지 않아 기본 폰트로 떨어지며 줄바꿈이 깨짐.
인식 테스트 결과 Noto Sans KR 사용. 폰트 테스트 파일 제거.

Co-Authored-By: Claude Opus 5.5 <noreply@anthropic.com>
Claude-Session: https://claude.ai/code/session_016jNE99rPd9by56Ho7H9dLa
</commit_message>
<xml_diff>
--- a/service/marketing-studio/samples/tips-v1/canva/TIPS_광고_피드_4x5.pptx
+++ b/service/marketing-studio/samples/tips-v1/canva/TIPS_광고_피드_4x5.pptx
@@ -3216,9 +3216,9 @@
                 <a:solidFill>
                   <a:srgbClr val="2DD4BF"/>
                 </a:solidFill>
-                <a:latin typeface="Pretendard"/>
-                <a:ea typeface="Pretendard"/>
-                <a:cs typeface="Pretendard"/>
+                <a:latin typeface="Noto Sans KR"/>
+                <a:ea typeface="Noto Sans KR"/>
+                <a:cs typeface="Noto Sans KR"/>
               </a:rPr>
               <a:t>개발자 없는 창업팀</a:t>
             </a:r>
@@ -3234,7 +3234,7 @@
         <p:spPr>
           <a:xfrm>
             <a:off x="838200" y="2038350"/>
-            <a:ext cx="6563910" cy="3207246"/>
+            <a:ext cx="7790780" cy="3207246"/>
           </a:xfrm>
           <a:prstGeom prst="rect">
             <a:avLst/>
@@ -3257,9 +3257,9 @@
                 <a:solidFill>
                   <a:srgbClr val="FFFFFF"/>
                 </a:solidFill>
-                <a:latin typeface="Pretendard"/>
-                <a:ea typeface="Pretendard"/>
-                <a:cs typeface="Pretendard"/>
+                <a:latin typeface="Noto Sans KR"/>
+                <a:ea typeface="Noto Sans KR"/>
+                <a:cs typeface="Noto Sans KR"/>
               </a:rPr>
               <a:t>TIPS 준비,</a:t>
             </a:r>
@@ -3275,9 +3275,9 @@
                 <a:solidFill>
                   <a:srgbClr val="FFFFFF"/>
                 </a:solidFill>
-                <a:latin typeface="Pretendard"/>
-                <a:ea typeface="Pretendard"/>
-                <a:cs typeface="Pretendard"/>
+                <a:latin typeface="Noto Sans KR"/>
+                <a:ea typeface="Noto Sans KR"/>
+                <a:cs typeface="Noto Sans KR"/>
               </a:rPr>
               <a:t>사업계획서보다</a:t>
             </a:r>
@@ -3293,9 +3293,9 @@
                 <a:solidFill>
                   <a:srgbClr val="2DD4BF"/>
                 </a:solidFill>
-                <a:latin typeface="Pretendard"/>
-                <a:ea typeface="Pretendard"/>
-                <a:cs typeface="Pretendard"/>
+                <a:latin typeface="Noto Sans KR"/>
+                <a:ea typeface="Noto Sans KR"/>
+                <a:cs typeface="Noto Sans KR"/>
               </a:rPr>
               <a:t>순서가 먼저입니다</a:t>
             </a:r>
@@ -3311,7 +3311,7 @@
         <p:spPr>
           <a:xfrm>
             <a:off x="838200" y="5610969"/>
-            <a:ext cx="4637529" cy="842962"/>
+            <a:ext cx="5519105" cy="842962"/>
           </a:xfrm>
           <a:prstGeom prst="rect">
             <a:avLst/>
@@ -3334,9 +3334,9 @@
                 <a:solidFill>
                   <a:srgbClr val="C5C8CF"/>
                 </a:solidFill>
-                <a:latin typeface="Pretendard"/>
-                <a:ea typeface="Pretendard"/>
-                <a:cs typeface="Pretendard"/>
+                <a:latin typeface="Noto Sans KR"/>
+                <a:ea typeface="Noto Sans KR"/>
+                <a:cs typeface="Noto Sans KR"/>
               </a:rPr>
               <a:t>사업 축과 기술 축이 만나는 자리,</a:t>
             </a:r>
@@ -3352,9 +3352,9 @@
                 <a:solidFill>
                   <a:srgbClr val="C5C8CF"/>
                 </a:solidFill>
-                <a:latin typeface="Pretendard"/>
-                <a:ea typeface="Pretendard"/>
-                <a:cs typeface="Pretendard"/>
+                <a:latin typeface="Noto Sans KR"/>
+                <a:ea typeface="Noto Sans KR"/>
+                <a:cs typeface="Noto Sans KR"/>
               </a:rPr>
               <a:t>우리 회사 지금 위치부터 진단합니다.</a:t>
             </a:r>
@@ -3435,9 +3435,9 @@
                 <a:solidFill>
                   <a:srgbClr val="2DD4BF"/>
                 </a:solidFill>
-                <a:latin typeface="Pretendard"/>
-                <a:ea typeface="Pretendard"/>
-                <a:cs typeface="Pretendard"/>
+                <a:latin typeface="Noto Sans KR"/>
+                <a:ea typeface="Noto Sans KR"/>
+                <a:cs typeface="Noto Sans KR"/>
               </a:rPr>
               <a:t>✓ </a:t>
             </a:r>
@@ -3446,9 +3446,9 @@
                 <a:solidFill>
                   <a:srgbClr val="FFFFFF"/>
                 </a:solidFill>
-                <a:latin typeface="Pretendard"/>
-                <a:ea typeface="Pretendard"/>
-                <a:cs typeface="Pretendard"/>
+                <a:latin typeface="Noto Sans KR"/>
+                <a:ea typeface="Noto Sans KR"/>
+                <a:cs typeface="Noto Sans KR"/>
               </a:rPr>
               <a:t>사업 축 정의</a:t>
             </a:r>
@@ -3529,9 +3529,9 @@
                 <a:solidFill>
                   <a:srgbClr val="2DD4BF"/>
                 </a:solidFill>
-                <a:latin typeface="Pretendard"/>
-                <a:ea typeface="Pretendard"/>
-                <a:cs typeface="Pretendard"/>
+                <a:latin typeface="Noto Sans KR"/>
+                <a:ea typeface="Noto Sans KR"/>
+                <a:cs typeface="Noto Sans KR"/>
               </a:rPr>
               <a:t>✓ </a:t>
             </a:r>
@@ -3540,9 +3540,9 @@
                 <a:solidFill>
                   <a:srgbClr val="FFFFFF"/>
                 </a:solidFill>
-                <a:latin typeface="Pretendard"/>
-                <a:ea typeface="Pretendard"/>
-                <a:cs typeface="Pretendard"/>
+                <a:latin typeface="Noto Sans KR"/>
+                <a:ea typeface="Noto Sans KR"/>
+                <a:cs typeface="Noto Sans KR"/>
               </a:rPr>
               <a:t>기술 축 3단 질문</a:t>
             </a:r>
@@ -3623,9 +3623,9 @@
                 <a:solidFill>
                   <a:srgbClr val="2DD4BF"/>
                 </a:solidFill>
-                <a:latin typeface="Pretendard"/>
-                <a:ea typeface="Pretendard"/>
-                <a:cs typeface="Pretendard"/>
+                <a:latin typeface="Noto Sans KR"/>
+                <a:ea typeface="Noto Sans KR"/>
+                <a:cs typeface="Noto Sans KR"/>
               </a:rPr>
               <a:t>✓ </a:t>
             </a:r>
@@ -3634,9 +3634,9 @@
                 <a:solidFill>
                   <a:srgbClr val="FFFFFF"/>
                 </a:solidFill>
-                <a:latin typeface="Pretendard"/>
-                <a:ea typeface="Pretendard"/>
-                <a:cs typeface="Pretendard"/>
+                <a:latin typeface="Noto Sans KR"/>
+                <a:ea typeface="Noto Sans KR"/>
+                <a:cs typeface="Noto Sans KR"/>
               </a:rPr>
               <a:t>현재 위치 진단</a:t>
             </a:r>
@@ -3739,9 +3739,9 @@
                 <a:solidFill>
                   <a:srgbClr val="FFFFFF"/>
                 </a:solidFill>
-                <a:latin typeface="Pretendard"/>
-                <a:ea typeface="Pretendard"/>
-                <a:cs typeface="Pretendard"/>
+                <a:latin typeface="Noto Sans KR"/>
+                <a:ea typeface="Noto Sans KR"/>
+                <a:cs typeface="Noto Sans KR"/>
               </a:rPr>
               <a:t>실제 진단 화면</a:t>
             </a:r>
@@ -3801,7 +3801,7 @@
         <p:spPr>
           <a:xfrm>
             <a:off x="1219200" y="11510962"/>
-            <a:ext cx="3110749" cy="409575"/>
+            <a:ext cx="3718657" cy="409575"/>
           </a:xfrm>
           <a:prstGeom prst="rect">
             <a:avLst/>
@@ -3820,9 +3820,9 @@
                 <a:solidFill>
                   <a:srgbClr val="16243D"/>
                 </a:solidFill>
-                <a:latin typeface="Pretendard"/>
-                <a:ea typeface="Pretendard"/>
-                <a:cs typeface="Pretendard"/>
+                <a:latin typeface="Noto Sans KR"/>
+                <a:ea typeface="Noto Sans KR"/>
+                <a:cs typeface="Noto Sans KR"/>
               </a:rPr>
               <a:t>AX 수준 진단받아보기</a:t>
             </a:r>
@@ -3838,7 +3838,7 @@
         <p:spPr>
           <a:xfrm>
             <a:off x="8760916" y="11510962"/>
-            <a:ext cx="363397" cy="409575"/>
+            <a:ext cx="478854" cy="409575"/>
           </a:xfrm>
           <a:prstGeom prst="rect">
             <a:avLst/>
@@ -3857,9 +3857,9 @@
                 <a:solidFill>
                   <a:srgbClr val="16243D"/>
                 </a:solidFill>
-                <a:latin typeface="Pretendard"/>
-                <a:ea typeface="Pretendard"/>
-                <a:cs typeface="Pretendard"/>
+                <a:latin typeface="Noto Sans KR"/>
+                <a:ea typeface="Noto Sans KR"/>
+                <a:cs typeface="Noto Sans KR"/>
               </a:rPr>
               <a:t>→</a:t>
             </a:r>

</xml_diff>

<commit_message>
marketing-studio: Canva 이관 레이어를 Noto Sans KR 기준으로 재측정
Canva 렌더 폰트(Noto Sans KR 400/700)로 HTML을 다시 측정해 배지·형광펜·칩
위치를 맞추고, 텍스트 박스 top 을 CSS 줄 박스 기준으로 보정. 폰트 테스트 파일 제거.

Co-Authored-By: Claude Opus 5.5 <noreply@anthropic.com>
Claude-Session: https://claude.ai/code/session_016jNE99rPd9by56Ho7H9dLa
</commit_message>
<xml_diff>
--- a/service/marketing-studio/samples/tips-v1/canva/TIPS_광고_피드_4x5.pptx
+++ b/service/marketing-studio/samples/tips-v1/canva/TIPS_광고_피드_4x5.pptx
@@ -3112,7 +3112,7 @@
         </p:blipFill>
         <p:spPr>
           <a:xfrm>
-            <a:off x="838200" y="962025"/>
+            <a:off x="838200" y="963811"/>
             <a:ext cx="540544" cy="381000"/>
           </a:xfrm>
           <a:prstGeom prst="rect">
@@ -3136,7 +3136,7 @@
         </p:blipFill>
         <p:spPr>
           <a:xfrm>
-            <a:off x="1512094" y="1009650"/>
+            <a:off x="1512094" y="1011436"/>
             <a:ext cx="1728043" cy="285750"/>
           </a:xfrm>
           <a:prstGeom prst="rect">
@@ -3152,8 +3152,8 @@
         </p:nvSpPr>
         <p:spPr>
           <a:xfrm>
-            <a:off x="7504212" y="914400"/>
-            <a:ext cx="1944588" cy="476250"/>
+            <a:off x="7392888" y="914400"/>
+            <a:ext cx="2055912" cy="479971"/>
           </a:xfrm>
           <a:prstGeom prst="roundRect">
             <a:avLst>
@@ -3196,8 +3196,8 @@
         </p:nvSpPr>
         <p:spPr>
           <a:xfrm>
-            <a:off x="7504212" y="914400"/>
-            <a:ext cx="1944588" cy="476250"/>
+            <a:off x="7392888" y="914400"/>
+            <a:ext cx="2055912" cy="479971"/>
           </a:xfrm>
           <a:prstGeom prst="rect">
             <a:avLst/>
@@ -3210,7 +3210,11 @@
           </a:bodyPr>
           <a:lstStyle/>
           <a:p>
-            <a:pPr algn="ctr"/>
+            <a:pPr algn="ctr">
+              <a:lnSpc>
+                <a:spcPts val="1979"/>
+              </a:lnSpc>
+            </a:pPr>
             <a:r>
               <a:rPr sz="1650" b="1" spc="-18">
                 <a:solidFill>
@@ -3233,8 +3237,8 @@
         </p:nvSpPr>
         <p:spPr>
           <a:xfrm>
-            <a:off x="838200" y="2038350"/>
-            <a:ext cx="7790780" cy="3207246"/>
+            <a:off x="838200" y="2059406"/>
+            <a:ext cx="8364885" cy="3182100"/>
           </a:xfrm>
           <a:prstGeom prst="rect">
             <a:avLst/>
@@ -3310,8 +3314,8 @@
         </p:nvSpPr>
         <p:spPr>
           <a:xfrm>
-            <a:off x="838200" y="5610969"/>
-            <a:ext cx="5519105" cy="842962"/>
+            <a:off x="838200" y="5559921"/>
+            <a:ext cx="5909965" cy="942975"/>
           </a:xfrm>
           <a:prstGeom prst="rect">
             <a:avLst/>
@@ -3369,12 +3373,12 @@
         </p:nvSpPr>
         <p:spPr>
           <a:xfrm>
-            <a:off x="838200" y="6925419"/>
-            <a:ext cx="1890117" cy="581025"/>
+            <a:off x="838200" y="6929140"/>
+            <a:ext cx="2033141" cy="582811"/>
           </a:xfrm>
           <a:prstGeom prst="roundRect">
             <a:avLst>
-              <a:gd name="adj" fmla="val 22950"/>
+              <a:gd name="adj" fmla="val 22880"/>
             </a:avLst>
           </a:prstGeom>
           <a:solidFill>
@@ -3415,8 +3419,8 @@
         </p:nvSpPr>
         <p:spPr>
           <a:xfrm>
-            <a:off x="838200" y="6925419"/>
-            <a:ext cx="1890117" cy="581025"/>
+            <a:off x="838200" y="6929140"/>
+            <a:ext cx="2033141" cy="582811"/>
           </a:xfrm>
           <a:prstGeom prst="rect">
             <a:avLst/>
@@ -3429,7 +3433,11 @@
           </a:bodyPr>
           <a:lstStyle/>
           <a:p>
-            <a:pPr algn="ctr"/>
+            <a:pPr algn="ctr">
+              <a:lnSpc>
+                <a:spcPts val="2340"/>
+              </a:lnSpc>
+            </a:pPr>
             <a:r>
               <a:rPr sz="1950" b="1">
                 <a:solidFill>
@@ -3463,12 +3471,12 @@
         </p:nvSpPr>
         <p:spPr>
           <a:xfrm>
-            <a:off x="2861667" y="6925419"/>
-            <a:ext cx="2319338" cy="581025"/>
+            <a:off x="3004691" y="6929140"/>
+            <a:ext cx="2476351" cy="582811"/>
           </a:xfrm>
           <a:prstGeom prst="roundRect">
             <a:avLst>
-              <a:gd name="adj" fmla="val 22950"/>
+              <a:gd name="adj" fmla="val 22880"/>
             </a:avLst>
           </a:prstGeom>
           <a:solidFill>
@@ -3509,8 +3517,8 @@
         </p:nvSpPr>
         <p:spPr>
           <a:xfrm>
-            <a:off x="2861667" y="6925419"/>
-            <a:ext cx="2319338" cy="581025"/>
+            <a:off x="3004691" y="6929140"/>
+            <a:ext cx="2476351" cy="582811"/>
           </a:xfrm>
           <a:prstGeom prst="rect">
             <a:avLst/>
@@ -3523,7 +3531,11 @@
           </a:bodyPr>
           <a:lstStyle/>
           <a:p>
-            <a:pPr algn="ctr"/>
+            <a:pPr algn="ctr">
+              <a:lnSpc>
+                <a:spcPts val="2340"/>
+              </a:lnSpc>
+            </a:pPr>
             <a:r>
               <a:rPr sz="1950" b="1">
                 <a:solidFill>
@@ -3557,12 +3569,12 @@
         </p:nvSpPr>
         <p:spPr>
           <a:xfrm>
-            <a:off x="5314355" y="6925419"/>
-            <a:ext cx="2104132" cy="581025"/>
+            <a:off x="5614392" y="6929140"/>
+            <a:ext cx="2260997" cy="582811"/>
           </a:xfrm>
           <a:prstGeom prst="roundRect">
             <a:avLst>
-              <a:gd name="adj" fmla="val 22950"/>
+              <a:gd name="adj" fmla="val 22880"/>
             </a:avLst>
           </a:prstGeom>
           <a:solidFill>
@@ -3603,8 +3615,8 @@
         </p:nvSpPr>
         <p:spPr>
           <a:xfrm>
-            <a:off x="5314355" y="6925419"/>
-            <a:ext cx="2104132" cy="581025"/>
+            <a:off x="5614392" y="6929140"/>
+            <a:ext cx="2260997" cy="582811"/>
           </a:xfrm>
           <a:prstGeom prst="rect">
             <a:avLst/>
@@ -3617,7 +3629,11 @@
           </a:bodyPr>
           <a:lstStyle/>
           <a:p>
-            <a:pPr algn="ctr"/>
+            <a:pPr algn="ctr">
+              <a:lnSpc>
+                <a:spcPts val="2340"/>
+              </a:lnSpc>
+            </a:pPr>
             <a:r>
               <a:rPr sz="1950" b="1">
                 <a:solidFill>
@@ -3676,7 +3692,7 @@
         <p:spPr>
           <a:xfrm>
             <a:off x="1047750" y="8077200"/>
-            <a:ext cx="1304330" cy="342900"/>
+            <a:ext cx="1386929" cy="342900"/>
           </a:xfrm>
           <a:prstGeom prst="roundRect">
             <a:avLst>
@@ -3720,7 +3736,7 @@
         <p:spPr>
           <a:xfrm>
             <a:off x="1047750" y="8077200"/>
-            <a:ext cx="1304330" cy="342900"/>
+            <a:ext cx="1386929" cy="342900"/>
           </a:xfrm>
           <a:prstGeom prst="rect">
             <a:avLst/>
@@ -3733,7 +3749,11 @@
           </a:bodyPr>
           <a:lstStyle/>
           <a:p>
-            <a:pPr algn="ctr"/>
+            <a:pPr algn="ctr">
+              <a:lnSpc>
+                <a:spcPts val="1800"/>
+              </a:lnSpc>
+            </a:pPr>
             <a:r>
               <a:rPr sz="1500" b="1">
                 <a:solidFill>
@@ -3800,8 +3820,8 @@
         </p:nvSpPr>
         <p:spPr>
           <a:xfrm>
-            <a:off x="1219200" y="11510962"/>
-            <a:ext cx="3718657" cy="409575"/>
+            <a:off x="1219200" y="11504355"/>
+            <a:ext cx="3874926" cy="411480"/>
           </a:xfrm>
           <a:prstGeom prst="rect">
             <a:avLst/>
@@ -3814,7 +3834,11 @@
           </a:bodyPr>
           <a:lstStyle/>
           <a:p>
-            <a:pPr algn="l"/>
+            <a:pPr algn="l">
+              <a:lnSpc>
+                <a:spcPts val="3240"/>
+              </a:lnSpc>
+            </a:pPr>
             <a:r>
               <a:rPr sz="2700" b="1" spc="-81">
                 <a:solidFill>
@@ -3837,8 +3861,8 @@
         </p:nvSpPr>
         <p:spPr>
           <a:xfrm>
-            <a:off x="8760916" y="11510962"/>
-            <a:ext cx="478854" cy="409575"/>
+            <a:off x="8735169" y="11504355"/>
+            <a:ext cx="511039" cy="411480"/>
           </a:xfrm>
           <a:prstGeom prst="rect">
             <a:avLst/>
@@ -3851,7 +3875,11 @@
           </a:bodyPr>
           <a:lstStyle/>
           <a:p>
-            <a:pPr algn="l"/>
+            <a:pPr algn="l">
+              <a:lnSpc>
+                <a:spcPts val="3240"/>
+              </a:lnSpc>
+            </a:pPr>
             <a:r>
               <a:rPr sz="2700" b="1" spc="-81">
                 <a:solidFill>

</xml_diff>